<commit_message>
Rebuild the BRD-03 Product Maintenance sign-off files 00 to 06 with the rate exception approval and the recaptured screenshots
The FRS words retirement and renewal requests in business terms and quotes the
current refusal messages; the deliverables README counts the 95 screenshots.
</commit_message>
<xml_diff>
--- a/docs/deliverables/out/Drop-0_Setup_and_Data_Migration/BRD-03_Product_Maintenance/01_BIBS_GuideDeck_BRD-03_Product_Maintenance_v2.0.pptx
+++ b/docs/deliverables/out/Drop-0_Setup_and_Data_Migration/BRD-03_Product_Maintenance/01_BIBS_GuideDeck_BRD-03_Product_Maintenance_v2.0.pptx
@@ -7661,7 +7661,7 @@
                 </a:solidFill>
                 <a:latin typeface="Arial"/>
               </a:rPr>
-              <a:t>Full list: FRS chapter 13 per screen, 75 rules on the Business rules sheet and 255 messages in chapter 15 and on the Messages sheet</a:t>
+              <a:t>Full list: FRS chapter 13 per screen, 77 rules on the Business rules sheet and 261 messages in chapter 15 and on the Messages sheet</a:t>
             </a:r>
           </a:p>
         </p:txBody>
@@ -12238,7 +12238,7 @@
                 </a:solidFill>
                 <a:latin typeface="Arial"/>
               </a:rPr>
-              <a:t>Content: 22 screens, 303 fields, 75 business rules, 255 messages, from the system as built</a:t>
+              <a:t>Content: 22 screens, 312 fields, 77 business rules, 261 messages, from the system as built</a:t>
             </a:r>
           </a:p>
           <a:p>

</xml_diff>

<commit_message>
Rebuild the BRD-01, BRD-03 and BRD-11 sign-off sets v2.0 (00-06) with the retaken screenshots; record names in words in the not found messages read from the code; BRD-12 personas in the BRD-11 role matrix
</commit_message>
<xml_diff>
--- a/docs/deliverables/out/Drop-0_Setup_and_Data_Migration/BRD-03_Product_Maintenance/01_BIBS_GuideDeck_BRD-03_Product_Maintenance_v2.0.pptx
+++ b/docs/deliverables/out/Drop-0_Setup_and_Data_Migration/BRD-03_Product_Maintenance/01_BIBS_GuideDeck_BRD-03_Product_Maintenance_v2.0.pptx
@@ -1081,7 +1081,7 @@
           <a:lstStyle/>
           <a:p>
             <a:r>
-              <a:t>The sign-off meeting starts when the exit criteria are met; the set is done when the certificate is signed and the build is frozen.</a:t>
+              <a:t>The sign-off meeting starts when the exit criteria are met; the set is done when the certificate is signed and the content of the set is frozen.</a:t>
             </a:r>
           </a:p>
         </p:txBody>
@@ -1151,7 +1151,7 @@
           <a:lstStyle/>
           <a:p>
             <a:r>
-              <a:t>Product Maintenance is already built: handover means the build is frozen as signed, the approved deltas are scheduled and the configuration inputs are loaded.</a:t>
+              <a:t>After sign-off the content is frozen as signed, the approved deltas are scheduled and the configuration inputs are loaded.</a:t>
             </a:r>
           </a:p>
         </p:txBody>
@@ -1221,7 +1221,7 @@
           <a:lstStyle/>
           <a:p>
             <a:r>
-              <a:t>Nothing in a signed set changes without a request in the register. The as-built refresh at the end of the build re-issues the set with the system as delivered.</a:t>
+              <a:t>Nothing in a signed set changes without a request in the register.</a:t>
             </a:r>
           </a:p>
         </p:txBody>
@@ -1376,7 +1376,7 @@
           <a:lstStyle/>
           <a:p>
             <a:r>
-              <a:t>Stress that the pack describes the system as built on the status date, not a design.</a:t>
+              <a:t>Stress that the pack shows the screens, fields, rules and messages the business is asked to confirm.</a:t>
             </a:r>
           </a:p>
           <a:p>
@@ -1696,7 +1696,7 @@
           </a:p>
           <a:p>
             <a:r>
-              <a:t>7. Handover to development or build freeze; configuration and migration inputs: From Tue 1-Dec-2026; templates final at the map freeze.</a:t>
+              <a:t>7. Content freeze; configuration and migration inputs: From Tue 1-Dec-2026; templates final at the map freeze.</a:t>
             </a:r>
           </a:p>
           <a:p>
@@ -6974,8 +6974,8 @@
         </p:blipFill>
         <p:spPr>
           <a:xfrm>
-            <a:off x="7953384" y="1325880"/>
-            <a:ext cx="1969292" cy="1874520"/>
+            <a:off x="8280702" y="1325880"/>
+            <a:ext cx="1314657" cy="1874520"/>
           </a:xfrm>
           <a:prstGeom prst="rect">
             <a:avLst/>
@@ -7038,8 +7038,8 @@
         </p:blipFill>
         <p:spPr>
           <a:xfrm>
-            <a:off x="1982802" y="3566160"/>
-            <a:ext cx="2541722" cy="1874520"/>
+            <a:off x="2272417" y="3566160"/>
+            <a:ext cx="1962493" cy="1874520"/>
           </a:xfrm>
           <a:prstGeom prst="rect">
             <a:avLst/>
@@ -7102,8 +7102,8 @@
         </p:blipFill>
         <p:spPr>
           <a:xfrm>
-            <a:off x="8123465" y="3566160"/>
-            <a:ext cx="1629131" cy="1874520"/>
+            <a:off x="7643719" y="3566160"/>
+            <a:ext cx="2588622" cy="1874520"/>
           </a:xfrm>
           <a:prstGeom prst="rect">
             <a:avLst/>
@@ -8506,7 +8506,7 @@
                           </a:solidFill>
                           <a:latin typeface="Arial"/>
                         </a:rPr>
-                        <a:t>Designed but not yet built</a:t>
+                        <a:t>Items that belong to other sets</a:t>
                       </a:r>
                     </a:p>
                   </a:txBody>
@@ -8528,7 +8528,7 @@
                           </a:solidFill>
                           <a:latin typeface="Arial"/>
                         </a:rPr>
-                        <a:t>The package map (data migration object R06) and the Renewal sanitation check PACKAGE_REMAP are designed in the Data Migration and Renewal sets and not in the build of this set.</a:t>
+                        <a:t>The package map (data migration object R06) and the Renewal sanitation check PACKAGE_REMAP belong to the Data Migration and Renewal sets.</a:t>
                       </a:r>
                     </a:p>
                   </a:txBody>
@@ -8618,7 +8618,7 @@
                           </a:solidFill>
                           <a:latin typeface="Arial"/>
                         </a:rPr>
-                        <a:t>Built as a port that records each change; the transport is a change request once the specification arrives.</a:t>
+                        <a:t>BIBS records each change for the transfer; the transfer is a change request once the specification arrives.</a:t>
                       </a:r>
                     </a:p>
                   </a:txBody>
@@ -8664,7 +8664,7 @@
                           </a:solidFill>
                           <a:latin typeface="Arial"/>
                         </a:rPr>
-                        <a:t>Open questions of FRS section 10.3 (product matrix, approval chain, ManCom quorum, validator role, CPC2) are built on the assumptions of section 10.1.</a:t>
+                        <a:t>Open questions of FRS section 10.3 (product matrix, approval chain, ManCom quorum, validator role, CPC2) follow the assumptions of section 10.1; chapter 22 lists the proposed rules for confirmation.</a:t>
                       </a:r>
                     </a:p>
                   </a:txBody>
@@ -9142,7 +9142,7 @@
                           </a:solidFill>
                           <a:latin typeface="Arial"/>
                         </a:rPr>
-                        <a:t>Designed but not yet built</a:t>
+                        <a:t>Items that belong to other sets</a:t>
                       </a:r>
                     </a:p>
                   </a:txBody>
@@ -9164,7 +9164,7 @@
                           </a:solidFill>
                           <a:latin typeface="Arial"/>
                         </a:rPr>
-                        <a:t>The template CI-07 of this set is the layout TSU prepares; it is loaded when the migration loaders are built.</a:t>
+                        <a:t>The template CI-07 of this set is the layout TSU prepares; it is loaded with the data migration.</a:t>
                       </a:r>
                     </a:p>
                   </a:txBody>
@@ -9210,7 +9210,7 @@
                           </a:solidFill>
                           <a:latin typeface="Arial"/>
                         </a:rPr>
-                        <a:t>When BDOI names the receiving system, an adapter sends each released version; the screens do not change.</a:t>
+                        <a:t>When BDOI names the receiving system, each released version is sent to it; the screens do not change.</a:t>
                       </a:r>
                     </a:p>
                   </a:txBody>
@@ -9256,7 +9256,7 @@
                           </a:solidFill>
                           <a:latin typeface="Arial"/>
                         </a:rPr>
-                        <a:t>The service level hours of each stage are parameters: a changed answer to PQ08 is a configuration change, not a build.</a:t>
+                        <a:t>The service level hours of each stage are parameters: a changed answer to PQ08 is a configuration change, not a change request.</a:t>
                       </a:r>
                     </a:p>
                   </a:txBody>
@@ -9704,7 +9704,7 @@
                 </a:solidFill>
                 <a:latin typeface="Arial"/>
               </a:rPr>
-              <a:t>The set is built from the system as built and every screenshot is taken on the SIT environment with seed data.</a:t>
+              <a:t>Every screenshot of the set is taken on the SIT environment with seed data.</a:t>
             </a:r>
           </a:p>
           <a:p>
@@ -10194,7 +10194,7 @@
                 </a:solidFill>
                 <a:latin typeface="Arial"/>
               </a:rPr>
-              <a:t>Build frozen as signed; deltas listed in the Change Management Register with mandays.</a:t>
+              <a:t>Content frozen as signed; deltas listed in the Change Management Register with mandays.</a:t>
             </a:r>
           </a:p>
           <a:p>
@@ -10296,7 +10296,7 @@
                 </a:solidFill>
                 <a:latin typeface="Arial"/>
               </a:rPr>
-              <a:t>Handover to development: build readiness checklist</a:t>
+              <a:t>After sign-off: readiness checklist</a:t>
             </a:r>
           </a:p>
         </p:txBody>
@@ -10685,7 +10685,7 @@
                 </a:solidFill>
                 <a:latin typeface="Arial"/>
               </a:rPr>
-              <a:t>Product Maintenance is already built: handover means the build is frozen as signed, the approved deltas are scheduled and the configuration inputs are loaded.</a:t>
+              <a:t>After sign-off the content is frozen as signed, the approved deltas are scheduled and the configuration inputs are loaded.</a:t>
             </a:r>
           </a:p>
         </p:txBody>
@@ -12213,7 +12213,7 @@
                 </a:solidFill>
                 <a:latin typeface="Arial"/>
               </a:rPr>
-              <a:t>The pack shows Product Maintenance as built in BIBS, screen by screen, so each business unit confirms what it will get</a:t>
+              <a:t>The pack shows the proposed Product Maintenance of BIBS, screen by screen, so each business unit confirms what it will get</a:t>
             </a:r>
           </a:p>
           <a:p>
@@ -12238,7 +12238,7 @@
                 </a:solidFill>
                 <a:latin typeface="Arial"/>
               </a:rPr>
-              <a:t>Content: 22 screens, 312 fields, 77 business rules, 261 messages, from the system as built</a:t>
+              <a:t>Content: 22 screens, 312 fields, 77 business rules, 261 messages</a:t>
             </a:r>
           </a:p>
           <a:p>
@@ -14121,7 +14121,7 @@
                           </a:solidFill>
                           <a:latin typeface="Arial"/>
                         </a:rPr>
-                        <a:t>00 Start Here; 01 Guide deck; FRS chapters 1-3 (context and personas), 10.4 (differences from the BRD), 14 (walkthroughs), 19 (configuration inputs) and 21 (sign-off); workbook Sign-off certificate</a:t>
+                        <a:t>00 Start Here; 01 Guide deck; FRS chapters 1-3 (context and personas), 22 (proposed rules for confirmation), 14 (walkthroughs), 19 (configuration inputs) and 21 (sign-off); workbook Sign-off certificate</a:t>
                       </a:r>
                     </a:p>
                   </a:txBody>
@@ -15570,7 +15570,7 @@
                 </a:solidFill>
                 <a:latin typeface="Arial"/>
               </a:rPr>
-              <a:t>One consolidated comments log, each item typed (clarification, defect, change request) and answered; Q&amp;A minutes</a:t>
+              <a:t>One consolidated comments log, each item typed (clarification, correction, change request) and answered; Q&amp;A minutes</a:t>
             </a:r>
           </a:p>
         </p:txBody>
@@ -16222,7 +16222,7 @@
                 </a:solidFill>
                 <a:latin typeface="Arial"/>
               </a:rPr>
-              <a:t>Handover to development or build freeze; configuration and migration inputs</a:t>
+              <a:t>Content freeze; configuration and migration inputs</a:t>
             </a:r>
           </a:p>
         </p:txBody>
@@ -16256,7 +16256,7 @@
                 </a:solidFill>
                 <a:latin typeface="Arial"/>
               </a:rPr>
-              <a:t>Build frozen as signed; approved deltas scheduled in the Change Management Register; templates handed to the data migration mocks</a:t>
+              <a:t>Content frozen as signed; approved deltas scheduled in the Change Management Register; templates handed to the data migration mocks</a:t>
             </a:r>
           </a:p>
         </p:txBody>
@@ -17000,7 +17000,7 @@
                           </a:solidFill>
                           <a:latin typeface="Arial"/>
                         </a:rPr>
-                        <a:t>FRS v2.0, workbook, test plan, configuration input templates, guide and deck built from the system as built</a:t>
+                        <a:t>FRS v2.0, workbook, test plan, configuration input templates, guide and deck</a:t>
                       </a:r>
                     </a:p>
                   </a:txBody>
@@ -17358,7 +17358,7 @@
                           </a:solidFill>
                           <a:latin typeface="Arial"/>
                         </a:rPr>
-                        <a:t>One consolidated comments log, each item typed (clarification, defect, change request) and answered; Q&amp;A minutes</a:t>
+                        <a:t>One consolidated comments log, each item typed (clarification, correction, change request) and answered; Q&amp;A minutes</a:t>
                       </a:r>
                     </a:p>
                   </a:txBody>
@@ -17857,7 +17857,7 @@
                           </a:solidFill>
                           <a:latin typeface="Arial"/>
                         </a:rPr>
-                        <a:t>Agreed clarifications and defects</a:t>
+                        <a:t>Agreed clarifications and corrections</a:t>
                       </a:r>
                     </a:p>
                   </a:txBody>
@@ -18037,7 +18037,7 @@
                           </a:solidFill>
                           <a:latin typeface="Arial"/>
                         </a:rPr>
-                        <a:t>7. Handover to development or build freeze; configuration and migration inputs</a:t>
+                        <a:t>7. Content freeze; configuration and migration inputs</a:t>
                       </a:r>
                     </a:p>
                   </a:txBody>
@@ -18103,7 +18103,7 @@
                           </a:solidFill>
                           <a:latin typeface="Arial"/>
                         </a:rPr>
-                        <a:t>Build frozen as signed; approved deltas scheduled in the Change Management Register; templates handed to the data migration mocks</a:t>
+                        <a:t>Content frozen as signed; approved deltas scheduled in the Change Management Register; templates handed to the data migration mocks</a:t>
                       </a:r>
                     </a:p>
                   </a:txBody>
@@ -18537,7 +18537,7 @@
         <p:spPr>
           <a:xfrm>
             <a:off x="548640" y="1325880"/>
-            <a:ext cx="7498078" cy="2306365"/>
+            <a:ext cx="7498079" cy="2262578"/>
           </a:xfrm>
           <a:prstGeom prst="rect">
             <a:avLst/>

</xml_diff>

<commit_message>
BRD-03 sign-off set: Sales Organisation tree table, Package Version validation and rule parameters of the incentive criteria in the screen specifications, FRS, messages and test cases; screenshots retaken (sales organisation tree, actions menu and refused deactivation, package version header and validation, new incentive criterion, walkthrough steps A-16 and A-17); FRS, sign-off workbook, guide deck and test plan v2.0 rebuilt; allow-list entries of the former rule parameter texts removed from the pack check
</commit_message>
<xml_diff>
--- a/docs/deliverables/out/Drop-0_Setup_and_Data_Migration/BRD-03_Product_Maintenance/01_BIBS_GuideDeck_BRD-03_Product_Maintenance_v2.0.pptx
+++ b/docs/deliverables/out/Drop-0_Setup_and_Data_Migration/BRD-03_Product_Maintenance/01_BIBS_GuideDeck_BRD-03_Product_Maintenance_v2.0.pptx
@@ -9859,8 +9859,8 @@
         </p:blipFill>
         <p:spPr>
           <a:xfrm>
-            <a:off x="2272417" y="3566160"/>
-            <a:ext cx="1962493" cy="1874520"/>
+            <a:off x="2269753" y="3566160"/>
+            <a:ext cx="1967821" cy="1874520"/>
           </a:xfrm>
           <a:prstGeom prst="rect">
             <a:avLst/>
@@ -10482,7 +10482,7 @@
                 </a:solidFill>
                 <a:latin typeface="Arial"/>
               </a:rPr>
-              <a:t>Full list: FRS chapter 13 per screen, 77 rules on the Business rules sheet and 261 messages in FRS chapter 15 and on the Messages sheet</a:t>
+              <a:t>Full list: FRS chapter 13 per screen, 81 rules on the Business rules sheet and 275 messages in FRS chapter 15 and on the Messages sheet</a:t>
             </a:r>
           </a:p>
         </p:txBody>
@@ -12428,7 +12428,7 @@
                 </a:solidFill>
                 <a:latin typeface="Arial"/>
               </a:rPr>
-              <a:t>Content: 22 screens, 312 fields, 77 business rules, 261 messages</a:t>
+              <a:t>Content: 22 screens, 324 fields, 81 business rules, 275 messages</a:t>
             </a:r>
           </a:p>
           <a:p>

</xml_diff>

<commit_message>
Drop 0 sign-off sets BRD-03, BRD-11 and BRD-13 rebuilt on screenshots retaken on a fresh seed stack: issue 2.1 changes CHG-PM-2.1-01 to 05, CHG-UA-2.1-01 to 05 and CHG-DM-2.1-01 to 05 flagged in the UX documents; 00 to 09 of each set, the Drop 0 closure set and the drop indexes rebuilt with both logos; password steps of the BRD-11 walkthrough cropped to the password card; the closure asks for no parameter of the insurer suite and claims the seeded tax codes
</commit_message>
<xml_diff>
--- a/docs/deliverables/out/Drop-0_Setup_and_Data_Migration/BRD-03_Product_Maintenance/01_BIBS_GuideDeck_BRD-03_Product_Maintenance_v2.0.pptx
+++ b/docs/deliverables/out/Drop-0_Setup_and_Data_Migration/BRD-03_Product_Maintenance/01_BIBS_GuideDeck_BRD-03_Product_Maintenance_v2.0.pptx
@@ -5414,7 +5414,7 @@
       <p:grpSpPr/>
       <p:pic>
         <p:nvPicPr>
-          <p:cNvPr id="2" name="Picture 1" descr="bdo-insure.png"/>
+          <p:cNvPr id="2" name="Picture 1" descr="client-logo.png"/>
           <p:cNvPicPr>
             <a:picLocks noChangeAspect="1"/>
           </p:cNvPicPr>
@@ -5773,7 +5773,7 @@
       </p:sp>
       <p:pic>
         <p:nvPicPr>
-          <p:cNvPr id="4" name="Picture 3" descr="bdo-insure.png"/>
+          <p:cNvPr id="4" name="Picture 3" descr="client-logo.png"/>
           <p:cNvPicPr>
             <a:picLocks noChangeAspect="1"/>
           </p:cNvPicPr>
@@ -6742,7 +6742,7 @@
       </p:sp>
       <p:pic>
         <p:nvPicPr>
-          <p:cNvPr id="4" name="Picture 3" descr="bdo-insure.png"/>
+          <p:cNvPr id="4" name="Picture 3" descr="client-logo.png"/>
           <p:cNvPicPr>
             <a:picLocks noChangeAspect="1"/>
           </p:cNvPicPr>
@@ -7513,7 +7513,7 @@
       </p:sp>
       <p:pic>
         <p:nvPicPr>
-          <p:cNvPr id="4" name="Picture 3" descr="bdo-insure.png"/>
+          <p:cNvPr id="4" name="Picture 3" descr="client-logo.png"/>
           <p:cNvPicPr>
             <a:picLocks noChangeAspect="1"/>
           </p:cNvPicPr>
@@ -8284,7 +8284,7 @@
       </p:sp>
       <p:pic>
         <p:nvPicPr>
-          <p:cNvPr id="4" name="Picture 3" descr="bdo-insure.png"/>
+          <p:cNvPr id="4" name="Picture 3" descr="client-logo.png"/>
           <p:cNvPicPr>
             <a:picLocks noChangeAspect="1"/>
           </p:cNvPicPr>
@@ -8877,7 +8877,7 @@
       </p:sp>
       <p:pic>
         <p:nvPicPr>
-          <p:cNvPr id="4" name="Picture 3" descr="bdo-insure.png"/>
+          <p:cNvPr id="4" name="Picture 3" descr="client-logo.png"/>
           <p:cNvPicPr>
             <a:picLocks noChangeAspect="1"/>
           </p:cNvPicPr>
@@ -9209,7 +9209,7 @@
       </p:sp>
       <p:pic>
         <p:nvPicPr>
-          <p:cNvPr id="4" name="Picture 3" descr="bdo-insure.png"/>
+          <p:cNvPr id="4" name="Picture 3" descr="client-logo.png"/>
           <p:cNvPicPr>
             <a:picLocks noChangeAspect="1"/>
           </p:cNvPicPr>
@@ -10585,7 +10585,7 @@
       </p:sp>
       <p:pic>
         <p:nvPicPr>
-          <p:cNvPr id="4" name="Picture 3" descr="bdo-insure.png"/>
+          <p:cNvPr id="4" name="Picture 3" descr="client-logo.png"/>
           <p:cNvPicPr>
             <a:picLocks noChangeAspect="1"/>
           </p:cNvPicPr>
@@ -10835,8 +10835,8 @@
         </p:blipFill>
         <p:spPr>
           <a:xfrm>
-            <a:off x="8278309" y="1325880"/>
-            <a:ext cx="1319443" cy="1874519"/>
+            <a:off x="8280702" y="1325880"/>
+            <a:ext cx="1314657" cy="1874520"/>
           </a:xfrm>
           <a:prstGeom prst="rect">
             <a:avLst/>
@@ -10899,8 +10899,8 @@
         </p:blipFill>
         <p:spPr>
           <a:xfrm>
-            <a:off x="2269753" y="3566160"/>
-            <a:ext cx="1967821" cy="1874520"/>
+            <a:off x="2272417" y="3566160"/>
+            <a:ext cx="1962493" cy="1874520"/>
           </a:xfrm>
           <a:prstGeom prst="rect">
             <a:avLst/>
@@ -11109,7 +11109,7 @@
       </p:sp>
       <p:pic>
         <p:nvPicPr>
-          <p:cNvPr id="4" name="Picture 3" descr="bdo-insure.png"/>
+          <p:cNvPr id="4" name="Picture 3" descr="client-logo.png"/>
           <p:cNvPicPr>
             <a:picLocks noChangeAspect="1"/>
           </p:cNvPicPr>
@@ -11522,7 +11522,7 @@
                 </a:solidFill>
                 <a:latin typeface="Arial"/>
               </a:rPr>
-              <a:t>Full list: FRS chapter 13 per screen, 81 rules on the Business rules sheet and 275 messages in FRS chapter 15 and on the Messages sheet</a:t>
+              <a:t>Full list: FRS chapter 13 per screen, 84 rules on the Business rules sheet and 276 messages in FRS chapter 15 and on the Messages sheet</a:t>
             </a:r>
           </a:p>
         </p:txBody>
@@ -11625,7 +11625,7 @@
       </p:sp>
       <p:pic>
         <p:nvPicPr>
-          <p:cNvPr id="4" name="Picture 3" descr="bdo-insure.png"/>
+          <p:cNvPr id="4" name="Picture 3" descr="client-logo.png"/>
           <p:cNvPicPr>
             <a:picLocks noChangeAspect="1"/>
           </p:cNvPicPr>
@@ -11957,7 +11957,7 @@
       </p:sp>
       <p:pic>
         <p:nvPicPr>
-          <p:cNvPr id="4" name="Picture 3" descr="bdo-insure.png"/>
+          <p:cNvPr id="4" name="Picture 3" descr="client-logo.png"/>
           <p:cNvPicPr>
             <a:picLocks noChangeAspect="1"/>
           </p:cNvPicPr>
@@ -12660,7 +12660,7 @@
       </p:sp>
       <p:pic>
         <p:nvPicPr>
-          <p:cNvPr id="4" name="Picture 3" descr="bdo-insure.png"/>
+          <p:cNvPr id="4" name="Picture 3" descr="client-logo.png"/>
           <p:cNvPicPr>
             <a:picLocks noChangeAspect="1"/>
           </p:cNvPicPr>
@@ -12898,7 +12898,7 @@
                 </a:solidFill>
                 <a:latin typeface="Arial"/>
               </a:rPr>
-              <a:t>Content: 22 screens, 324 fields, 81 business rules, 275 messages</a:t>
+              <a:t>Content: 22 screens, 324 fields, 84 business rules, 276 messages</a:t>
             </a:r>
           </a:p>
           <a:p>
@@ -13126,7 +13126,7 @@
       </p:sp>
       <p:pic>
         <p:nvPicPr>
-          <p:cNvPr id="4" name="Picture 3" descr="bdo-insure.png"/>
+          <p:cNvPr id="4" name="Picture 3" descr="client-logo.png"/>
           <p:cNvPicPr>
             <a:picLocks noChangeAspect="1"/>
           </p:cNvPicPr>
@@ -13696,7 +13696,7 @@
       </p:sp>
       <p:pic>
         <p:nvPicPr>
-          <p:cNvPr id="4" name="Picture 3" descr="bdo-insure.png"/>
+          <p:cNvPr id="4" name="Picture 3" descr="client-logo.png"/>
           <p:cNvPicPr>
             <a:picLocks noChangeAspect="1"/>
           </p:cNvPicPr>
@@ -14674,7 +14674,7 @@
       </p:sp>
       <p:pic>
         <p:nvPicPr>
-          <p:cNvPr id="4" name="Picture 3" descr="bdo-insure.png"/>
+          <p:cNvPr id="4" name="Picture 3" descr="client-logo.png"/>
           <p:cNvPicPr>
             <a:picLocks noChangeAspect="1"/>
           </p:cNvPicPr>
@@ -15115,7 +15115,7 @@
       </p:sp>
       <p:pic>
         <p:nvPicPr>
-          <p:cNvPr id="4" name="Picture 3" descr="bdo-insure.png"/>
+          <p:cNvPr id="4" name="Picture 3" descr="client-logo.png"/>
           <p:cNvPicPr>
             <a:picLocks noChangeAspect="1"/>
           </p:cNvPicPr>
@@ -15556,7 +15556,7 @@
       </p:sp>
       <p:pic>
         <p:nvPicPr>
-          <p:cNvPr id="4" name="Picture 3" descr="bdo-insure.png"/>
+          <p:cNvPr id="4" name="Picture 3" descr="client-logo.png"/>
           <p:cNvPicPr>
             <a:picLocks noChangeAspect="1"/>
           </p:cNvPicPr>
@@ -16327,7 +16327,7 @@
       </p:sp>
       <p:pic>
         <p:nvPicPr>
-          <p:cNvPr id="4" name="Picture 3" descr="bdo-insure.png"/>
+          <p:cNvPr id="4" name="Picture 3" descr="client-logo.png"/>
           <p:cNvPicPr>
             <a:picLocks noChangeAspect="1"/>
           </p:cNvPicPr>
@@ -16693,7 +16693,7 @@
       </p:sp>
       <p:pic>
         <p:nvPicPr>
-          <p:cNvPr id="4" name="Picture 3" descr="bdo-insure.png"/>
+          <p:cNvPr id="4" name="Picture 3" descr="client-logo.png"/>
           <p:cNvPicPr>
             <a:picLocks noChangeAspect="1"/>
           </p:cNvPicPr>
@@ -17529,7 +17529,7 @@
       </p:sp>
       <p:pic>
         <p:nvPicPr>
-          <p:cNvPr id="4" name="Picture 3" descr="bdo-insure.png"/>
+          <p:cNvPr id="4" name="Picture 3" descr="client-logo.png"/>
           <p:cNvPicPr>
             <a:picLocks noChangeAspect="1"/>
           </p:cNvPicPr>
@@ -18365,7 +18365,7 @@
       </p:sp>
       <p:pic>
         <p:nvPicPr>
-          <p:cNvPr id="4" name="Picture 3" descr="bdo-insure.png"/>
+          <p:cNvPr id="4" name="Picture 3" descr="client-logo.png"/>
           <p:cNvPicPr>
             <a:picLocks noChangeAspect="1"/>
           </p:cNvPicPr>
@@ -19073,7 +19073,7 @@
       </p:sp>
       <p:pic>
         <p:nvPicPr>
-          <p:cNvPr id="4" name="Picture 3" descr="bdo-insure.png"/>
+          <p:cNvPr id="4" name="Picture 3" descr="client-logo.png"/>
           <p:cNvPicPr>
             <a:picLocks noChangeAspect="1"/>
           </p:cNvPicPr>
@@ -21199,7 +21199,7 @@
       </p:sp>
       <p:pic>
         <p:nvPicPr>
-          <p:cNvPr id="4" name="Picture 3" descr="bdo-insure.png"/>
+          <p:cNvPr id="4" name="Picture 3" descr="client-logo.png"/>
           <p:cNvPicPr>
             <a:picLocks noChangeAspect="1"/>
           </p:cNvPicPr>
@@ -22056,7 +22056,7 @@
       </p:sp>
       <p:pic>
         <p:nvPicPr>
-          <p:cNvPr id="4" name="Picture 3" descr="bdo-insure.png"/>
+          <p:cNvPr id="4" name="Picture 3" descr="client-logo.png"/>
           <p:cNvPicPr>
             <a:picLocks noChangeAspect="1"/>
           </p:cNvPicPr>
@@ -22913,7 +22913,7 @@
       </p:sp>
       <p:pic>
         <p:nvPicPr>
-          <p:cNvPr id="4" name="Picture 3" descr="bdo-insure.png"/>
+          <p:cNvPr id="4" name="Picture 3" descr="client-logo.png"/>
           <p:cNvPicPr>
             <a:picLocks noChangeAspect="1"/>
           </p:cNvPicPr>

</xml_diff>

<commit_message>
BRD-03 Product Maintenance screenshots retaken in the BDO style-guide presentation on a fresh seed stack: 126 images; FRS, guide deck, sign-off workbook and UX documents 07 to 09 rebuilt at v2.0 with issue 2.2 change CHG-PM-2.2-01; insurer responses described with their row action menu; capture opens a row action when the button is in the menu
</commit_message>
<xml_diff>
--- a/docs/deliverables/out/Drop-0_Setup_and_Data_Migration/BRD-03_Product_Maintenance/01_BIBS_GuideDeck_BRD-03_Product_Maintenance_v2.0.pptx
+++ b/docs/deliverables/out/Drop-0_Setup_and_Data_Migration/BRD-03_Product_Maintenance/01_BIBS_GuideDeck_BRD-03_Product_Maintenance_v2.0.pptx
@@ -10835,8 +10835,8 @@
         </p:blipFill>
         <p:spPr>
           <a:xfrm>
-            <a:off x="8280702" y="1325880"/>
-            <a:ext cx="1314657" cy="1874520"/>
+            <a:off x="8233415" y="1325880"/>
+            <a:ext cx="1409230" cy="1874519"/>
           </a:xfrm>
           <a:prstGeom prst="rect">
             <a:avLst/>
@@ -12898,7 +12898,7 @@
                 </a:solidFill>
                 <a:latin typeface="Arial"/>
               </a:rPr>
-              <a:t>Content: 22 screens, 324 fields, 84 business rules, 276 messages</a:t>
+              <a:t>Content: 22 screens, 325 fields, 84 business rules, 276 messages</a:t>
             </a:r>
           </a:p>
           <a:p>

</xml_diff>